<commit_message>
chore(presentation): update decks, add overview presentation
Ultraworked with [Sisyphus](https://github.com/code-yeongyu/oh-my-openagent)

Co-authored-by: Sisyphus <clio-agent@sisyphuslabs.ai>
</commit_message>
<xml_diff>
--- a/Презентация/готовые/РЕХАУ Калькулятор снеготаяния — быстрый старт.pptx
+++ b/Презентация/готовые/РЕХАУ Калькулятор снеготаяния — быстрый старт.pptx
@@ -140,9 +140,35 @@
           </a:ln>
         </p:spPr>
       </p:pic>
-      <p:sp>
-        <p:nvSpPr>
-          <p:cNvPr id="4" name="accent-bar"/>
+      <p:pic>
+        <p:nvPicPr>
+          <p:cNvPr id="4" name="app-icon"/>
+          <p:cNvPicPr/>
+          <p:nvPr/>
+        </p:nvPicPr>
+        <p:blipFill>
+          <a:blip r:embed="rId4"/>
+          <a:srcRect l="0" r="0"/>
+          <a:stretch>
+            <a:fillRect/>
+          </a:stretch>
+        </p:blipFill>
+        <p:spPr>
+          <a:xfrm>
+            <a:off x="10058400" y="2844800"/>
+            <a:ext cx="1371600" cy="1371600"/>
+          </a:xfrm>
+          <a:prstGeom prst="rect">
+            <a:avLst/>
+          </a:prstGeom>
+          <a:ln>
+            <a:noFill/>
+          </a:ln>
+        </p:spPr>
+      </p:pic>
+      <p:sp>
+        <p:nvSpPr>
+          <p:cNvPr id="5" name="accent-bar"/>
           <p:cNvSpPr/>
           <p:nvPr/>
         </p:nvSpPr>
@@ -164,7 +190,7 @@
       </p:sp>
       <p:sp>
         <p:nvSpPr>
-          <p:cNvPr id="5" name="title"/>
+          <p:cNvPr id="6" name="title"/>
           <p:cNvSpPr txBox="1"/>
           <p:nvPr/>
         </p:nvSpPr>
@@ -191,7 +217,7 @@
               </a:lnSpc>
             </a:pPr>
             <a:r>
-              <a:rPr lang="en-US" sz="4200" b="1">
+              <a:rPr lang="en-US" sz="4200" noProof="1" b="1">
                 <a:solidFill>
                   <a:srgbClr val="000000"/>
                 </a:solidFill>
@@ -200,13 +226,13 @@
               </a:rPr>
               <a:t>Быстрый старт</a:t>
             </a:r>
-            <a:endParaRPr lang="en-US" sz="4200"/>
-          </a:p>
-        </p:txBody>
-      </p:sp>
-      <p:sp>
-        <p:nvSpPr>
-          <p:cNvPr id="6" name="subtitle"/>
+            <a:endParaRPr lang="en-US" sz="4200" noProof="1"/>
+          </a:p>
+        </p:txBody>
+      </p:sp>
+      <p:sp>
+        <p:nvSpPr>
+          <p:cNvPr id="7" name="subtitle"/>
           <p:cNvSpPr txBox="1"/>
           <p:nvPr/>
         </p:nvSpPr>
@@ -233,7 +259,7 @@
               </a:lnSpc>
             </a:pPr>
             <a:r>
-              <a:rPr lang="en-US" sz="1700">
+              <a:rPr lang="en-US" sz="1700" noProof="1">
                 <a:solidFill>
                   <a:srgbClr val="4E4E4E"/>
                 </a:solidFill>
@@ -242,18 +268,18 @@
               </a:rPr>
               <a:t>Калькулятор снеготаяния РЕХАУ: как пройти путь от нового проекта до готового отчёта PDF</a:t>
             </a:r>
-            <a:endParaRPr lang="en-US" sz="1700"/>
+            <a:endParaRPr lang="en-US" sz="1700" noProof="1"/>
           </a:p>
         </p:txBody>
       </p:sp>
       <p:pic>
         <p:nvPicPr>
-          <p:cNvPr id="7" name="squares-br"/>
+          <p:cNvPr id="8" name="squares-br"/>
           <p:cNvPicPr/>
           <p:nvPr/>
         </p:nvPicPr>
         <p:blipFill>
-          <a:blip r:embed="rId4"/>
+          <a:blip r:embed="rId5"/>
           <a:srcRect l="-36" r="-36"/>
           <a:stretch>
             <a:fillRect/>
@@ -274,7 +300,7 @@
       </p:pic>
       <p:sp>
         <p:nvSpPr>
-          <p:cNvPr id="8" name="slogan"/>
+          <p:cNvPr id="9" name="slogan"/>
           <p:cNvSpPr txBox="1"/>
           <p:nvPr/>
         </p:nvSpPr>
@@ -301,7 +327,7 @@
               </a:lnSpc>
             </a:pPr>
             <a:r>
-              <a:rPr lang="en-US" sz="1300">
+              <a:rPr lang="en-US" sz="1300" noProof="1">
                 <a:solidFill>
                   <a:srgbClr val="818181"/>
                 </a:solidFill>
@@ -310,20 +336,20 @@
               </a:rPr>
               <a:t>Решения для дома и бизнеса</a:t>
             </a:r>
-            <a:endParaRPr lang="en-US" sz="1300"/>
-          </a:p>
-        </p:txBody>
-      </p:sp>
-      <p:sp>
-        <p:nvSpPr>
-          <p:cNvPr id="9" name="meta"/>
+            <a:endParaRPr lang="en-US" sz="1300" noProof="1"/>
+          </a:p>
+        </p:txBody>
+      </p:sp>
+      <p:sp>
+        <p:nvSpPr>
+          <p:cNvPr id="10" name="meta"/>
           <p:cNvSpPr txBox="1"/>
           <p:nvPr/>
         </p:nvSpPr>
         <p:spPr>
           <a:xfrm>
             <a:off x="5842000" y="6070600"/>
-            <a:ext cx="5588000" cy="279400"/>
+            <a:ext cx="4826000" cy="279400"/>
           </a:xfrm>
           <a:prstGeom prst="rect">
             <a:avLst/>
@@ -343,7 +369,7 @@
               </a:lnSpc>
             </a:pPr>
             <a:r>
-              <a:rPr lang="en-US" sz="1200">
+              <a:rPr lang="en-US" sz="1200" noProof="1">
                 <a:solidFill>
                   <a:srgbClr val="B0B0B0"/>
                 </a:solidFill>
@@ -352,7 +378,7 @@
               </a:rPr>
               <a:t>Обучающая презентация для пользователей · v1.0 · 2026</a:t>
             </a:r>
-            <a:endParaRPr lang="en-US" sz="1200"/>
+            <a:endParaRPr lang="en-US" sz="1200" noProof="1"/>
           </a:p>
         </p:txBody>
       </p:sp>
@@ -420,7 +446,7 @@
               </a:lnSpc>
             </a:pPr>
             <a:r>
-              <a:rPr lang="en-US" sz="1200" b="1" spc="200" kern="0">
+              <a:rPr lang="en-US" sz="1200" noProof="1" b="1" spc="200" kern="0">
                 <a:solidFill>
                   <a:srgbClr val="E50040"/>
                 </a:solidFill>
@@ -429,7 +455,7 @@
               </a:rPr>
               <a:t>ВОПРОСЫ И ОТВЕТЫ</a:t>
             </a:r>
-            <a:endParaRPr lang="en-US" sz="1200"/>
+            <a:endParaRPr lang="en-US" sz="1200" noProof="1"/>
           </a:p>
         </p:txBody>
       </p:sp>
@@ -462,7 +488,7 @@
               </a:lnSpc>
             </a:pPr>
             <a:r>
-              <a:rPr lang="en-US" sz="3000" b="1">
+              <a:rPr lang="en-US" sz="3000" noProof="1" b="1">
                 <a:solidFill>
                   <a:srgbClr val="000000"/>
                 </a:solidFill>
@@ -471,7 +497,7 @@
               </a:rPr>
               <a:t>Частые вопросы</a:t>
             </a:r>
-            <a:endParaRPr lang="en-US" sz="3000"/>
+            <a:endParaRPr lang="en-US" sz="3000" noProof="1"/>
           </a:p>
         </p:txBody>
       </p:sp>
@@ -552,7 +578,7 @@
               </a:lnSpc>
             </a:pPr>
             <a:r>
-              <a:rPr lang="en-US" sz="1500" b="1">
+              <a:rPr lang="en-US" sz="1500" noProof="1" b="1">
                 <a:solidFill>
                   <a:srgbClr val="E50040"/>
                 </a:solidFill>
@@ -561,7 +587,7 @@
               </a:rPr>
               <a:t>Моего города нет в базе — что делать?</a:t>
             </a:r>
-            <a:endParaRPr lang="en-US" sz="1500"/>
+            <a:endParaRPr lang="en-US" sz="1500" noProof="1"/>
           </a:p>
         </p:txBody>
       </p:sp>
@@ -594,7 +620,7 @@
               </a:lnSpc>
             </a:pPr>
             <a:r>
-              <a:rPr lang="en-US" sz="1300">
+              <a:rPr lang="en-US" sz="1300" noProof="1">
                 <a:solidFill>
                   <a:srgbClr val="4E4E4E"/>
                 </a:solidFill>
@@ -603,7 +629,7 @@
               </a:rPr>
               <a:t>Выберите ближайший город с похожим климатом и скорректируйте температуру, ветер и влажность вручную по СП 131.13330.2025</a:t>
             </a:r>
-            <a:endParaRPr lang="en-US" sz="1300"/>
+            <a:endParaRPr lang="en-US" sz="1300" noProof="1"/>
           </a:p>
         </p:txBody>
       </p:sp>
@@ -662,7 +688,7 @@
               </a:lnSpc>
             </a:pPr>
             <a:r>
-              <a:rPr lang="en-US" sz="1500" b="1">
+              <a:rPr lang="en-US" sz="1500" noProof="1" b="1">
                 <a:solidFill>
                   <a:srgbClr val="E50040"/>
                 </a:solidFill>
@@ -671,7 +697,7 @@
               </a:rPr>
               <a:t>Можно ли вернуться к проекту позже?</a:t>
             </a:r>
-            <a:endParaRPr lang="en-US" sz="1500"/>
+            <a:endParaRPr lang="en-US" sz="1500" noProof="1"/>
           </a:p>
         </p:txBody>
       </p:sp>
@@ -704,7 +730,7 @@
               </a:lnSpc>
             </a:pPr>
             <a:r>
-              <a:rPr lang="en-US" sz="1300">
+              <a:rPr lang="en-US" sz="1300" noProof="1">
                 <a:solidFill>
                   <a:srgbClr val="4E4E4E"/>
                 </a:solidFill>
@@ -713,7 +739,7 @@
               </a:rPr>
               <a:t>Да. Сохраните проект кнопкой «Сохранить» — файл .smc содержит все введённые данные и открывается через меню «Файл»</a:t>
             </a:r>
-            <a:endParaRPr lang="en-US" sz="1300"/>
+            <a:endParaRPr lang="en-US" sz="1300" noProof="1"/>
           </a:p>
         </p:txBody>
       </p:sp>
@@ -772,7 +798,7 @@
               </a:lnSpc>
             </a:pPr>
             <a:r>
-              <a:rPr lang="en-US" sz="1500" b="1">
+              <a:rPr lang="en-US" sz="1500" noProof="1" b="1">
                 <a:solidFill>
                   <a:srgbClr val="E50040"/>
                 </a:solidFill>
@@ -781,7 +807,7 @@
               </a:rPr>
               <a:t>Чем отличаются рабочий и холодный режимы?</a:t>
             </a:r>
-            <a:endParaRPr lang="en-US" sz="1500"/>
+            <a:endParaRPr lang="en-US" sz="1500" noProof="1"/>
           </a:p>
         </p:txBody>
       </p:sp>
@@ -814,7 +840,7 @@
               </a:lnSpc>
             </a:pPr>
             <a:r>
-              <a:rPr lang="en-US" sz="1300">
+              <a:rPr lang="en-US" sz="1300" noProof="1">
                 <a:solidFill>
                   <a:srgbClr val="4E4E4E"/>
                 </a:solidFill>
@@ -823,7 +849,7 @@
               </a:rPr>
               <a:t>Холодный учитывает вязкость гликоля при запуске системы на морозе: потери давления выше — проверяйте оба значения ΔP в результатах</a:t>
             </a:r>
-            <a:endParaRPr lang="en-US" sz="1300"/>
+            <a:endParaRPr lang="en-US" sz="1300" noProof="1"/>
           </a:p>
         </p:txBody>
       </p:sp>
@@ -882,7 +908,7 @@
               </a:lnSpc>
             </a:pPr>
             <a:r>
-              <a:rPr lang="en-US" sz="1500" b="1">
+              <a:rPr lang="en-US" sz="1500" noProof="1" b="1">
                 <a:solidFill>
                   <a:srgbClr val="E50040"/>
                 </a:solidFill>
@@ -891,7 +917,7 @@
               </a:rPr>
               <a:t>Куда передавать результаты?</a:t>
             </a:r>
-            <a:endParaRPr lang="en-US" sz="1500"/>
+            <a:endParaRPr lang="en-US" sz="1500" noProof="1"/>
           </a:p>
         </p:txBody>
       </p:sp>
@@ -924,7 +950,7 @@
               </a:lnSpc>
             </a:pPr>
             <a:r>
-              <a:rPr lang="en-US" sz="1300">
+              <a:rPr lang="en-US" sz="1300" noProof="1">
                 <a:solidFill>
                   <a:srgbClr val="4E4E4E"/>
                 </a:solidFill>
@@ -933,7 +959,7 @@
               </a:rPr>
               <a:t>PDF-отчёт — заказчику и в проектную документацию; обороты вентилей — монтажникам для балансировки; ведомость — в закупку</a:t>
             </a:r>
-            <a:endParaRPr lang="en-US" sz="1300"/>
+            <a:endParaRPr lang="en-US" sz="1300" noProof="1"/>
           </a:p>
         </p:txBody>
       </p:sp>
@@ -992,7 +1018,7 @@
               </a:lnSpc>
             </a:pPr>
             <a:r>
-              <a:rPr lang="en-US" sz="1100">
+              <a:rPr lang="en-US" sz="1100" noProof="1">
                 <a:solidFill>
                   <a:srgbClr val="818181"/>
                 </a:solidFill>
@@ -1001,7 +1027,7 @@
               </a:rPr>
               <a:t>10</a:t>
             </a:r>
-            <a:endParaRPr lang="en-US" sz="1100"/>
+            <a:endParaRPr lang="en-US" sz="1100" noProof="1"/>
           </a:p>
         </p:txBody>
       </p:sp>
@@ -1145,7 +1171,7 @@
               </a:lnSpc>
             </a:pPr>
             <a:r>
-              <a:rPr lang="en-US" sz="2000">
+              <a:rPr lang="en-US" sz="2000" noProof="1">
                 <a:solidFill>
                   <a:srgbClr val="FFFFFF"/>
                 </a:solidFill>
@@ -1154,19 +1180,61 @@
               </a:rPr>
               <a:t>Решения для дома и бизнеса</a:t>
             </a:r>
-            <a:endParaRPr lang="en-US" sz="2000"/>
-          </a:p>
-        </p:txBody>
-      </p:sp>
-      <p:sp>
-        <p:nvSpPr>
-          <p:cNvPr id="6" name="contacts"/>
-          <p:cNvSpPr txBox="1"/>
-          <p:nvPr/>
-        </p:nvSpPr>
-        <p:spPr>
-          <a:xfrm>
-            <a:off x="762000" y="5461000"/>
+            <a:endParaRPr lang="en-US" sz="2000" noProof="1"/>
+          </a:p>
+        </p:txBody>
+      </p:sp>
+      <p:sp>
+        <p:nvSpPr>
+          <p:cNvPr id="6" name="manual-note"/>
+          <p:cNvSpPr txBox="1"/>
+          <p:nvPr/>
+        </p:nvSpPr>
+        <p:spPr>
+          <a:xfrm>
+            <a:off x="762000" y="4876800"/>
+            <a:ext cx="6096000" cy="508000"/>
+          </a:xfrm>
+          <a:prstGeom prst="rect">
+            <a:avLst/>
+          </a:prstGeom>
+          <a:noFill/>
+          <a:ln>
+            <a:noFill/>
+          </a:ln>
+        </p:spPr>
+        <p:txBody>
+          <a:bodyPr lIns="0" rIns="0" tIns="0" bIns="0" wrap="square" rtlCol="0" anchor="t"/>
+          <a:lstStyle/>
+          <a:p>
+            <a:pPr algn="l">
+              <a:lnSpc>
+                <a:spcPct val="140000"/>
+              </a:lnSpc>
+            </a:pPr>
+            <a:r>
+              <a:rPr lang="en-US" sz="1200" noProof="1">
+                <a:solidFill>
+                  <a:srgbClr val="B0B0B0"/>
+                </a:solidFill>
+                <a:latin typeface="MiSans"/>
+                <a:ea typeface="MiSans"/>
+              </a:rPr>
+              <a:t>В комплекте — руководство пользователя: все расчёты разобраны по шагам на сквозном примере (Екатеринбург, 370 м²)</a:t>
+            </a:r>
+            <a:endParaRPr lang="en-US" sz="1200" noProof="1"/>
+          </a:p>
+        </p:txBody>
+      </p:sp>
+      <p:sp>
+        <p:nvSpPr>
+          <p:cNvPr id="7" name="contacts"/>
+          <p:cNvSpPr txBox="1"/>
+          <p:nvPr/>
+        </p:nvSpPr>
+        <p:spPr>
+          <a:xfrm>
+            <a:off x="762000" y="5511800"/>
             <a:ext cx="6096000" cy="889000"/>
           </a:xfrm>
           <a:prstGeom prst="rect">
@@ -1187,16 +1255,16 @@
               </a:lnSpc>
             </a:pPr>
             <a:r>
-              <a:rPr lang="en-US" sz="1300">
+              <a:rPr lang="en-US" sz="1300" noProof="1">
                 <a:solidFill>
                   <a:srgbClr val="B0B0B0"/>
                 </a:solidFill>
                 <a:latin typeface="MiSans"/>
                 <a:ea typeface="MiSans"/>
               </a:rPr>
-              <a:t>Автор и контакты — placeholder</a:t>
-            </a:r>
-            <a:endParaRPr lang="en-US" sz="1300"/>
+              <a:t>Автор: Асадуллин Айдар</a:t>
+            </a:r>
+            <a:endParaRPr lang="en-US" sz="1300" noProof="1"/>
           </a:p>
           <a:p>
             <a:pPr algn="l">
@@ -1205,22 +1273,22 @@
               </a:lnSpc>
             </a:pPr>
             <a:r>
-              <a:rPr lang="en-US" sz="1300">
+              <a:rPr lang="en-US" sz="1300" noProof="1">
                 <a:solidFill>
                   <a:srgbClr val="B0B0B0"/>
                 </a:solidFill>
                 <a:latin typeface="MiSans"/>
                 <a:ea typeface="MiSans"/>
               </a:rPr>
-              <a:t>e-mail · телефон · сайт</a:t>
-            </a:r>
-            <a:endParaRPr lang="en-US" sz="1300"/>
-          </a:p>
-        </p:txBody>
-      </p:sp>
-      <p:sp>
-        <p:nvSpPr>
-          <p:cNvPr id="7" name="page-num"/>
+              <a:t>aydar.asadullin@rhsolutions.ru · +7 922 157 01 80</a:t>
+            </a:r>
+            <a:endParaRPr lang="en-US" sz="1300" noProof="1"/>
+          </a:p>
+        </p:txBody>
+      </p:sp>
+      <p:sp>
+        <p:nvSpPr>
+          <p:cNvPr id="8" name="page-num"/>
           <p:cNvSpPr txBox="1"/>
           <p:nvPr/>
         </p:nvSpPr>
@@ -1247,7 +1315,7 @@
               </a:lnSpc>
             </a:pPr>
             <a:r>
-              <a:rPr lang="en-US" sz="1100">
+              <a:rPr lang="en-US" sz="1100" noProof="1">
                 <a:solidFill>
                   <a:srgbClr val="818181"/>
                 </a:solidFill>
@@ -1256,7 +1324,7 @@
               </a:rPr>
               <a:t>11</a:t>
             </a:r>
-            <a:endParaRPr lang="en-US" sz="1100"/>
+            <a:endParaRPr lang="en-US" sz="1100" noProof="1"/>
           </a:p>
         </p:txBody>
       </p:sp>
@@ -1324,7 +1392,7 @@
               </a:lnSpc>
             </a:pPr>
             <a:r>
-              <a:rPr lang="en-US" sz="1200" b="1" spc="200" kern="0">
+              <a:rPr lang="en-US" sz="1200" noProof="1" b="1" spc="200" kern="0">
                 <a:solidFill>
                   <a:srgbClr val="E50040"/>
                 </a:solidFill>
@@ -1333,7 +1401,7 @@
               </a:rPr>
               <a:t>УСТАНОВКА</a:t>
             </a:r>
-            <a:endParaRPr lang="en-US" sz="1200"/>
+            <a:endParaRPr lang="en-US" sz="1200" noProof="1"/>
           </a:p>
         </p:txBody>
       </p:sp>
@@ -1366,7 +1434,7 @@
               </a:lnSpc>
             </a:pPr>
             <a:r>
-              <a:rPr lang="en-US" sz="3000" b="1">
+              <a:rPr lang="en-US" sz="3000" noProof="1" b="1">
                 <a:solidFill>
                   <a:srgbClr val="000000"/>
                 </a:solidFill>
@@ -1375,7 +1443,7 @@
               </a:rPr>
               <a:t>Три шага до первого запуска</a:t>
             </a:r>
-            <a:endParaRPr lang="en-US" sz="3000"/>
+            <a:endParaRPr lang="en-US" sz="3000" noProof="1"/>
           </a:p>
         </p:txBody>
       </p:sp>
@@ -1454,7 +1522,7 @@
               </a:lnSpc>
             </a:pPr>
             <a:r>
-              <a:rPr lang="en-US" sz="1600" b="1">
+              <a:rPr lang="en-US" sz="1600" noProof="1" b="1">
                 <a:solidFill>
                   <a:srgbClr val="FFFFFF"/>
                 </a:solidFill>
@@ -1463,7 +1531,7 @@
               </a:rPr>
               <a:t>Системные требования</a:t>
             </a:r>
-            <a:endParaRPr lang="en-US" sz="1600"/>
+            <a:endParaRPr lang="en-US" sz="1600" noProof="1"/>
           </a:p>
         </p:txBody>
       </p:sp>
@@ -1496,7 +1564,7 @@
               </a:lnSpc>
             </a:pPr>
             <a:r>
-              <a:rPr lang="en-US" sz="1300" b="1">
+              <a:rPr lang="en-US" sz="1300" noProof="1" b="1">
                 <a:solidFill>
                   <a:srgbClr val="D9D9D9"/>
                 </a:solidFill>
@@ -1506,7 +1574,7 @@
               <a:t>ОС:</a:t>
             </a:r>
             <a:r>
-              <a:rPr lang="en-US" sz="1300">
+              <a:rPr lang="en-US" sz="1300" noProof="1">
                 <a:solidFill>
                   <a:srgbClr val="D9D9D9"/>
                 </a:solidFill>
@@ -1515,7 +1583,7 @@
               </a:rPr>
               <a:t> Windows 10 / 11 (x64)</a:t>
             </a:r>
-            <a:endParaRPr lang="en-US" sz="1300"/>
+            <a:endParaRPr lang="en-US" sz="1300" noProof="1"/>
           </a:p>
           <a:p>
             <a:pPr algn="l">
@@ -1527,7 +1595,7 @@
               </a:spcBef>
             </a:pPr>
             <a:r>
-              <a:rPr lang="en-US" sz="1300" b="1">
+              <a:rPr lang="en-US" sz="1300" noProof="1" b="1">
                 <a:solidFill>
                   <a:srgbClr val="D9D9D9"/>
                 </a:solidFill>
@@ -1537,7 +1605,7 @@
               <a:t>Платформа:</a:t>
             </a:r>
             <a:r>
-              <a:rPr lang="en-US" sz="1300">
+              <a:rPr lang="en-US" sz="1300" noProof="1">
                 <a:solidFill>
                   <a:srgbClr val="D9D9D9"/>
                 </a:solidFill>
@@ -1546,7 +1614,7 @@
               </a:rPr>
               <a:t> .NET 8 — уже входит в установщик, отдельно не нужна</a:t>
             </a:r>
-            <a:endParaRPr lang="en-US" sz="1300"/>
+            <a:endParaRPr lang="en-US" sz="1300" noProof="1"/>
           </a:p>
           <a:p>
             <a:pPr algn="l">
@@ -1558,7 +1626,7 @@
               </a:spcBef>
             </a:pPr>
             <a:r>
-              <a:rPr lang="en-US" sz="1300" b="1">
+              <a:rPr lang="en-US" sz="1300" noProof="1" b="1">
                 <a:solidFill>
                   <a:srgbClr val="D9D9D9"/>
                 </a:solidFill>
@@ -1568,7 +1636,7 @@
               <a:t>Экран:</a:t>
             </a:r>
             <a:r>
-              <a:rPr lang="en-US" sz="1300">
+              <a:rPr lang="en-US" sz="1300" noProof="1">
                 <a:solidFill>
                   <a:srgbClr val="D9D9D9"/>
                 </a:solidFill>
@@ -1577,7 +1645,7 @@
               </a:rPr>
               <a:t> от 1280×1024, лучше 1920×1080</a:t>
             </a:r>
-            <a:endParaRPr lang="en-US" sz="1300"/>
+            <a:endParaRPr lang="en-US" sz="1300" noProof="1"/>
           </a:p>
         </p:txBody>
       </p:sp>
@@ -1632,7 +1700,7 @@
               </a:lnSpc>
             </a:pPr>
             <a:r>
-              <a:rPr lang="en-US" sz="1500" b="1">
+              <a:rPr lang="en-US" sz="1500" noProof="1" b="1">
                 <a:solidFill>
                   <a:srgbClr val="FFFFFF"/>
                 </a:solidFill>
@@ -1641,7 +1709,7 @@
               </a:rPr>
               <a:t>1</a:t>
             </a:r>
-            <a:endParaRPr lang="en-US" sz="1500"/>
+            <a:endParaRPr lang="en-US" sz="1500" noProof="1"/>
           </a:p>
         </p:txBody>
       </p:sp>
@@ -1674,7 +1742,7 @@
               </a:lnSpc>
             </a:pPr>
             <a:r>
-              <a:rPr lang="en-US" sz="1400" b="1">
+              <a:rPr lang="en-US" sz="1400" noProof="1" b="1">
                 <a:solidFill>
                   <a:srgbClr val="4E4E4E"/>
                 </a:solidFill>
@@ -1684,7 +1752,7 @@
               <a:t>Запустите установщик</a:t>
             </a:r>
             <a:r>
-              <a:rPr lang="en-US" sz="1400">
+              <a:rPr lang="en-US" sz="1400" noProof="1">
                 <a:solidFill>
                   <a:srgbClr val="4E4E4E"/>
                 </a:solidFill>
@@ -1693,7 +1761,7 @@
               </a:rPr>
               <a:t> — файл SnowMeltingCalculator-v1.1-Setup.exe из полученного пакета</a:t>
             </a:r>
-            <a:endParaRPr lang="en-US" sz="1400"/>
+            <a:endParaRPr lang="en-US" sz="1400" noProof="1"/>
           </a:p>
         </p:txBody>
       </p:sp>
@@ -1748,7 +1816,7 @@
               </a:lnSpc>
             </a:pPr>
             <a:r>
-              <a:rPr lang="en-US" sz="1500" b="1">
+              <a:rPr lang="en-US" sz="1500" noProof="1" b="1">
                 <a:solidFill>
                   <a:srgbClr val="FFFFFF"/>
                 </a:solidFill>
@@ -1757,7 +1825,7 @@
               </a:rPr>
               <a:t>2</a:t>
             </a:r>
-            <a:endParaRPr lang="en-US" sz="1500"/>
+            <a:endParaRPr lang="en-US" sz="1500" noProof="1"/>
           </a:p>
         </p:txBody>
       </p:sp>
@@ -1790,7 +1858,7 @@
               </a:lnSpc>
             </a:pPr>
             <a:r>
-              <a:rPr lang="en-US" sz="1400" b="1">
+              <a:rPr lang="en-US" sz="1400" noProof="1" b="1">
                 <a:solidFill>
                   <a:srgbClr val="4E4E4E"/>
                 </a:solidFill>
@@ -1800,7 +1868,7 @@
               <a:t>Следуйте мастеру установки</a:t>
             </a:r>
             <a:r>
-              <a:rPr lang="en-US" sz="1400">
+              <a:rPr lang="en-US" sz="1400" noProof="1">
                 <a:solidFill>
                   <a:srgbClr val="4E4E4E"/>
                 </a:solidFill>
@@ -1809,7 +1877,7 @@
               </a:rPr>
               <a:t> — ярлык появится в меню «Пуск» (папка REHAU), при желании — на рабочем столе</a:t>
             </a:r>
-            <a:endParaRPr lang="en-US" sz="1400"/>
+            <a:endParaRPr lang="en-US" sz="1400" noProof="1"/>
           </a:p>
         </p:txBody>
       </p:sp>
@@ -1864,7 +1932,7 @@
               </a:lnSpc>
             </a:pPr>
             <a:r>
-              <a:rPr lang="en-US" sz="1500" b="1">
+              <a:rPr lang="en-US" sz="1500" noProof="1" b="1">
                 <a:solidFill>
                   <a:srgbClr val="000000"/>
                 </a:solidFill>
@@ -1873,7 +1941,7 @@
               </a:rPr>
               <a:t>3</a:t>
             </a:r>
-            <a:endParaRPr lang="en-US" sz="1500"/>
+            <a:endParaRPr lang="en-US" sz="1500" noProof="1"/>
           </a:p>
         </p:txBody>
       </p:sp>
@@ -1906,7 +1974,7 @@
               </a:lnSpc>
             </a:pPr>
             <a:r>
-              <a:rPr lang="en-US" sz="1400" b="1">
+              <a:rPr lang="en-US" sz="1400" noProof="1" b="1">
                 <a:solidFill>
                   <a:srgbClr val="4E4E4E"/>
                 </a:solidFill>
@@ -1916,7 +1984,7 @@
               <a:t>Запустите программу</a:t>
             </a:r>
             <a:r>
-              <a:rPr lang="en-US" sz="1400">
+              <a:rPr lang="en-US" sz="1400" noProof="1">
                 <a:solidFill>
                   <a:srgbClr val="4E4E4E"/>
                 </a:solidFill>
@@ -1925,7 +1993,7 @@
               </a:rPr>
               <a:t> — из меню «Пуск»; при первом запуске она сама проверит базу свойств гликолей и откроется на шаге «Климат»</a:t>
             </a:r>
-            <a:endParaRPr lang="en-US" sz="1400"/>
+            <a:endParaRPr lang="en-US" sz="1400" noProof="1"/>
           </a:p>
         </p:txBody>
       </p:sp>
@@ -1984,7 +2052,7 @@
               </a:lnSpc>
             </a:pPr>
             <a:r>
-              <a:rPr lang="en-US" sz="1300">
+              <a:rPr lang="en-US" sz="1300" noProof="1">
                 <a:solidFill>
                   <a:srgbClr val="4E4E4E"/>
                 </a:solidFill>
@@ -1994,7 +2062,7 @@
               <a:t>После установки файлы проектов </a:t>
             </a:r>
             <a:r>
-              <a:rPr lang="en-US" sz="1300" b="1">
+              <a:rPr lang="en-US" sz="1300" noProof="1" b="1">
                 <a:solidFill>
                   <a:srgbClr val="4E4E4E"/>
                 </a:solidFill>
@@ -2004,7 +2072,7 @@
               <a:t>.smc</a:t>
             </a:r>
             <a:r>
-              <a:rPr lang="en-US" sz="1300">
+              <a:rPr lang="en-US" sz="1300" noProof="1">
                 <a:solidFill>
                   <a:srgbClr val="4E4E4E"/>
                 </a:solidFill>
@@ -2013,7 +2081,7 @@
               </a:rPr>
               <a:t> открываются двойным кликом — расширение ассоциировано с программой</a:t>
             </a:r>
-            <a:endParaRPr lang="en-US" sz="1300"/>
+            <a:endParaRPr lang="en-US" sz="1300" noProof="1"/>
           </a:p>
         </p:txBody>
       </p:sp>
@@ -2072,7 +2140,7 @@
               </a:lnSpc>
             </a:pPr>
             <a:r>
-              <a:rPr lang="en-US" sz="1100">
+              <a:rPr lang="en-US" sz="1100" noProof="1">
                 <a:solidFill>
                   <a:srgbClr val="818181"/>
                 </a:solidFill>
@@ -2081,7 +2149,7 @@
               </a:rPr>
               <a:t>02</a:t>
             </a:r>
-            <a:endParaRPr lang="en-US" sz="1100"/>
+            <a:endParaRPr lang="en-US" sz="1100" noProof="1"/>
           </a:p>
         </p:txBody>
       </p:sp>
@@ -2149,7 +2217,7 @@
               </a:lnSpc>
             </a:pPr>
             <a:r>
-              <a:rPr lang="en-US" sz="1200" b="1" spc="200" kern="0">
+              <a:rPr lang="en-US" sz="1200" noProof="1" b="1" spc="200" kern="0">
                 <a:solidFill>
                   <a:srgbClr val="E50040"/>
                 </a:solidFill>
@@ -2158,7 +2226,7 @@
               </a:rPr>
               <a:t>ИНТЕРФЕЙС</a:t>
             </a:r>
-            <a:endParaRPr lang="en-US" sz="1200"/>
+            <a:endParaRPr lang="en-US" sz="1200" noProof="1"/>
           </a:p>
         </p:txBody>
       </p:sp>
@@ -2191,7 +2259,7 @@
               </a:lnSpc>
             </a:pPr>
             <a:r>
-              <a:rPr lang="en-US" sz="3000" b="1">
+              <a:rPr lang="en-US" sz="3000" noProof="1" b="1">
                 <a:solidFill>
                   <a:srgbClr val="000000"/>
                 </a:solidFill>
@@ -2200,7 +2268,7 @@
               </a:rPr>
               <a:t>Главное окно: три зоны</a:t>
             </a:r>
-            <a:endParaRPr lang="en-US" sz="3000"/>
+            <a:endParaRPr lang="en-US" sz="3000" noProof="1"/>
           </a:p>
         </p:txBody>
       </p:sp>
@@ -2277,7 +2345,7 @@
               </a:lnSpc>
             </a:pPr>
             <a:r>
-              <a:rPr lang="en-US" sz="1300" b="1">
+              <a:rPr lang="en-US" sz="1300" noProof="1" b="1">
                 <a:solidFill>
                   <a:srgbClr val="4E4E4E"/>
                 </a:solidFill>
@@ -2287,7 +2355,7 @@
               <a:t>Заголовок</a:t>
             </a:r>
             <a:r>
-              <a:rPr lang="en-US" sz="1300">
+              <a:rPr lang="en-US" sz="1300" noProof="1">
                 <a:solidFill>
                   <a:srgbClr val="4E4E4E"/>
                 </a:solidFill>
@@ -2296,7 +2364,7 @@
               </a:rPr>
               <a:t> — имя текущего шага, кнопки «Назад» / «Далее»</a:t>
             </a:r>
-            <a:endParaRPr lang="en-US" sz="1300"/>
+            <a:endParaRPr lang="en-US" sz="1300" noProof="1"/>
           </a:p>
         </p:txBody>
       </p:sp>
@@ -2351,7 +2419,7 @@
               </a:lnSpc>
             </a:pPr>
             <a:r>
-              <a:rPr lang="en-US" sz="1300" b="1">
+              <a:rPr lang="en-US" sz="1300" noProof="1" b="1">
                 <a:solidFill>
                   <a:srgbClr val="4E4E4E"/>
                 </a:solidFill>
@@ -2361,7 +2429,7 @@
               <a:t>Панель шагов слева</a:t>
             </a:r>
             <a:r>
-              <a:rPr lang="en-US" sz="1300">
+              <a:rPr lang="en-US" sz="1300" noProof="1">
                 <a:solidFill>
                   <a:srgbClr val="4E4E4E"/>
                 </a:solidFill>
@@ -2370,7 +2438,7 @@
               </a:rPr>
               <a:t> — Климат → Конструкция → Тепловой → Гидравлика → Результаты</a:t>
             </a:r>
-            <a:endParaRPr lang="en-US" sz="1300"/>
+            <a:endParaRPr lang="en-US" sz="1300" noProof="1"/>
           </a:p>
         </p:txBody>
       </p:sp>
@@ -2425,7 +2493,7 @@
               </a:lnSpc>
             </a:pPr>
             <a:r>
-              <a:rPr lang="en-US" sz="1300" b="1">
+              <a:rPr lang="en-US" sz="1300" noProof="1" b="1">
                 <a:solidFill>
                   <a:srgbClr val="4E4E4E"/>
                 </a:solidFill>
@@ -2435,7 +2503,7 @@
               <a:t>Рабочая область</a:t>
             </a:r>
             <a:r>
-              <a:rPr lang="en-US" sz="1300">
+              <a:rPr lang="en-US" sz="1300" noProof="1">
                 <a:solidFill>
                   <a:srgbClr val="4E4E4E"/>
                 </a:solidFill>
@@ -2444,7 +2512,7 @@
               </a:rPr>
               <a:t> — формы и таблицы текущего шага</a:t>
             </a:r>
-            <a:endParaRPr lang="en-US" sz="1300"/>
+            <a:endParaRPr lang="en-US" sz="1300" noProof="1"/>
           </a:p>
         </p:txBody>
       </p:sp>
@@ -2499,7 +2567,7 @@
               </a:lnSpc>
             </a:pPr>
             <a:r>
-              <a:rPr lang="en-US" sz="1300" b="1">
+              <a:rPr lang="en-US" sz="1300" noProof="1" b="1">
                 <a:solidFill>
                   <a:srgbClr val="4E4E4E"/>
                 </a:solidFill>
@@ -2509,7 +2577,7 @@
               <a:t>Бейджи состояния</a:t>
             </a:r>
             <a:r>
-              <a:rPr lang="en-US" sz="1300">
+              <a:rPr lang="en-US" sz="1300" noProof="1">
                 <a:solidFill>
                   <a:srgbClr val="4E4E4E"/>
                 </a:solidFill>
@@ -2518,7 +2586,7 @@
               </a:rPr>
               <a:t> — зелёный: данные актуальны; красный: нужен пересчёт</a:t>
             </a:r>
-            <a:endParaRPr lang="en-US" sz="1300"/>
+            <a:endParaRPr lang="en-US" sz="1300" noProof="1"/>
           </a:p>
         </p:txBody>
       </p:sp>
@@ -2551,7 +2619,7 @@
               </a:lnSpc>
             </a:pPr>
             <a:r>
-              <a:rPr lang="en-US" sz="1200">
+              <a:rPr lang="en-US" sz="1200" noProof="1">
                 <a:solidFill>
                   <a:srgbClr val="818181"/>
                 </a:solidFill>
@@ -2560,7 +2628,7 @@
               </a:rPr>
               <a:t>Совет: по шагам можно ходить в любую сторону — кликом по названию в панели или кнопками «Назад» / «Далее»</a:t>
             </a:r>
-            <a:endParaRPr lang="en-US" sz="1200"/>
+            <a:endParaRPr lang="en-US" sz="1200" noProof="1"/>
           </a:p>
         </p:txBody>
       </p:sp>
@@ -2648,7 +2716,7 @@
               </a:lnSpc>
             </a:pPr>
             <a:r>
-              <a:rPr lang="en-US" sz="1100">
+              <a:rPr lang="en-US" sz="1100" noProof="1">
                 <a:solidFill>
                   <a:srgbClr val="818181"/>
                 </a:solidFill>
@@ -2657,7 +2725,7 @@
               </a:rPr>
               <a:t>Главное окно программы — шаг «Климатические данные»</a:t>
             </a:r>
-            <a:endParaRPr lang="en-US" sz="1100"/>
+            <a:endParaRPr lang="en-US" sz="1100" noProof="1"/>
           </a:p>
         </p:txBody>
       </p:sp>
@@ -2716,7 +2784,7 @@
               </a:lnSpc>
             </a:pPr>
             <a:r>
-              <a:rPr lang="en-US" sz="1100">
+              <a:rPr lang="en-US" sz="1100" noProof="1">
                 <a:solidFill>
                   <a:srgbClr val="818181"/>
                 </a:solidFill>
@@ -2725,7 +2793,7 @@
               </a:rPr>
               <a:t>03</a:t>
             </a:r>
-            <a:endParaRPr lang="en-US" sz="1100"/>
+            <a:endParaRPr lang="en-US" sz="1100" noProof="1"/>
           </a:p>
         </p:txBody>
       </p:sp>
@@ -2793,7 +2861,7 @@
               </a:lnSpc>
             </a:pPr>
             <a:r>
-              <a:rPr lang="en-US" sz="1200" b="1" spc="200" kern="0">
+              <a:rPr lang="en-US" sz="1200" noProof="1" b="1" spc="200" kern="0">
                 <a:solidFill>
                   <a:srgbClr val="E50040"/>
                 </a:solidFill>
@@ -2802,7 +2870,7 @@
               </a:rPr>
               <a:t>ШАГ 1 · КЛИМАТ</a:t>
             </a:r>
-            <a:endParaRPr lang="en-US" sz="1200"/>
+            <a:endParaRPr lang="en-US" sz="1200" noProof="1"/>
           </a:p>
         </p:txBody>
       </p:sp>
@@ -2835,7 +2903,7 @@
               </a:lnSpc>
             </a:pPr>
             <a:r>
-              <a:rPr lang="en-US" sz="3000" b="1">
+              <a:rPr lang="en-US" sz="3000" noProof="1" b="1">
                 <a:solidFill>
                   <a:srgbClr val="000000"/>
                 </a:solidFill>
@@ -2844,7 +2912,7 @@
               </a:rPr>
               <a:t>Задайте климат объекта</a:t>
             </a:r>
-            <a:endParaRPr lang="en-US" sz="3000"/>
+            <a:endParaRPr lang="en-US" sz="3000" noProof="1"/>
           </a:p>
         </p:txBody>
       </p:sp>
@@ -2921,7 +2989,7 @@
               </a:lnSpc>
             </a:pPr>
             <a:r>
-              <a:rPr lang="en-US" sz="1300" b="1">
+              <a:rPr lang="en-US" sz="1300" noProof="1" b="1">
                 <a:solidFill>
                   <a:srgbClr val="4E4E4E"/>
                 </a:solidFill>
@@ -2931,7 +2999,7 @@
               <a:t>Начните вводить город</a:t>
             </a:r>
             <a:r>
-              <a:rPr lang="en-US" sz="1300">
+              <a:rPr lang="en-US" sz="1300" noProof="1">
                 <a:solidFill>
                   <a:srgbClr val="4E4E4E"/>
                 </a:solidFill>
@@ -2940,7 +3008,7 @@
               </a:rPr>
               <a:t> — подсказка найдёт его в базе 550 городов РФ</a:t>
             </a:r>
-            <a:endParaRPr lang="en-US" sz="1300"/>
+            <a:endParaRPr lang="en-US" sz="1300" noProof="1"/>
           </a:p>
         </p:txBody>
       </p:sp>
@@ -2995,7 +3063,7 @@
               </a:lnSpc>
             </a:pPr>
             <a:r>
-              <a:rPr lang="en-US" sz="1300" b="1">
+              <a:rPr lang="en-US" sz="1300" noProof="1" b="1">
                 <a:solidFill>
                   <a:srgbClr val="4E4E4E"/>
                 </a:solidFill>
@@ -3005,7 +3073,7 @@
               <a:t>Проверьте расчётную температуру</a:t>
             </a:r>
             <a:r>
-              <a:rPr lang="en-US" sz="1300">
+              <a:rPr lang="en-US" sz="1300" noProof="1">
                 <a:solidFill>
                   <a:srgbClr val="4E4E4E"/>
                 </a:solidFill>
@@ -3014,7 +3082,7 @@
               </a:rPr>
               <a:t> — программа выберет её автоматически (−10 / −15 / −20 °C)</a:t>
             </a:r>
-            <a:endParaRPr lang="en-US" sz="1300"/>
+            <a:endParaRPr lang="en-US" sz="1300" noProof="1"/>
           </a:p>
         </p:txBody>
       </p:sp>
@@ -3069,7 +3137,7 @@
               </a:lnSpc>
             </a:pPr>
             <a:r>
-              <a:rPr lang="en-US" sz="1300" b="1">
+              <a:rPr lang="en-US" sz="1300" noProof="1" b="1">
                 <a:solidFill>
                   <a:srgbClr val="4E4E4E"/>
                 </a:solidFill>
@@ -3079,7 +3147,7 @@
               <a:t>Введите снегопад</a:t>
             </a:r>
             <a:r>
-              <a:rPr lang="en-US" sz="1300">
+              <a:rPr lang="en-US" sz="1300" noProof="1">
                 <a:solidFill>
                   <a:srgbClr val="4E4E4E"/>
                 </a:solidFill>
@@ -3088,7 +3156,7 @@
               </a:rPr>
               <a:t> — в мм/ч по водяному эквиваленту: 1 мм/ч воды ≈ 1 см/ч снега</a:t>
             </a:r>
-            <a:endParaRPr lang="en-US" sz="1300"/>
+            <a:endParaRPr lang="en-US" sz="1300" noProof="1"/>
           </a:p>
         </p:txBody>
       </p:sp>
@@ -3143,7 +3211,7 @@
               </a:lnSpc>
             </a:pPr>
             <a:r>
-              <a:rPr lang="en-US" sz="1300" b="1">
+              <a:rPr lang="en-US" sz="1300" noProof="1" b="1">
                 <a:solidFill>
                   <a:srgbClr val="4E4E4E"/>
                 </a:solidFill>
@@ -3153,7 +3221,7 @@
               <a:t>Включите «Повышенные требования»</a:t>
             </a:r>
             <a:r>
-              <a:rPr lang="en-US" sz="1300">
+              <a:rPr lang="en-US" sz="1300" noProof="1">
                 <a:solidFill>
                   <a:srgbClr val="4E4E4E"/>
                 </a:solidFill>
@@ -3162,7 +3230,7 @@
               </a:rPr>
               <a:t> для ответственных объектов — расчёт пойдёт по −20 °C</a:t>
             </a:r>
-            <a:endParaRPr lang="en-US" sz="1300"/>
+            <a:endParaRPr lang="en-US" sz="1300" noProof="1"/>
           </a:p>
         </p:txBody>
       </p:sp>
@@ -3195,7 +3263,7 @@
               </a:lnSpc>
             </a:pPr>
             <a:r>
-              <a:rPr lang="en-US" sz="1200">
+              <a:rPr lang="en-US" sz="1200" noProof="1">
                 <a:solidFill>
                   <a:srgbClr val="818181"/>
                 </a:solidFill>
@@ -3204,7 +3272,7 @@
               </a:rPr>
               <a:t>Допустимый диапазон температур: −50…+10 °C. Все поля можно поправить вручную, кнопка «Сбросить» вернёт данные города</a:t>
             </a:r>
-            <a:endParaRPr lang="en-US" sz="1200"/>
+            <a:endParaRPr lang="en-US" sz="1200" noProof="1"/>
           </a:p>
         </p:txBody>
       </p:sp>
@@ -3292,7 +3360,7 @@
               </a:lnSpc>
             </a:pPr>
             <a:r>
-              <a:rPr lang="en-US" sz="1100">
+              <a:rPr lang="en-US" sz="1100" noProof="1">
                 <a:solidFill>
                   <a:srgbClr val="818181"/>
                 </a:solidFill>
@@ -3301,7 +3369,7 @@
               </a:rPr>
               <a:t>Шаг «Климат» — выбор города с автоподстановкой</a:t>
             </a:r>
-            <a:endParaRPr lang="en-US" sz="1100"/>
+            <a:endParaRPr lang="en-US" sz="1100" noProof="1"/>
           </a:p>
         </p:txBody>
       </p:sp>
@@ -3360,7 +3428,7 @@
               </a:lnSpc>
             </a:pPr>
             <a:r>
-              <a:rPr lang="en-US" sz="1100">
+              <a:rPr lang="en-US" sz="1100" noProof="1">
                 <a:solidFill>
                   <a:srgbClr val="818181"/>
                 </a:solidFill>
@@ -3369,7 +3437,7 @@
               </a:rPr>
               <a:t>04</a:t>
             </a:r>
-            <a:endParaRPr lang="en-US" sz="1100"/>
+            <a:endParaRPr lang="en-US" sz="1100" noProof="1"/>
           </a:p>
         </p:txBody>
       </p:sp>
@@ -3437,7 +3505,7 @@
               </a:lnSpc>
             </a:pPr>
             <a:r>
-              <a:rPr lang="en-US" sz="1200" b="1" spc="200" kern="0">
+              <a:rPr lang="en-US" sz="1200" noProof="1" b="1" spc="200" kern="0">
                 <a:solidFill>
                   <a:srgbClr val="E50040"/>
                 </a:solidFill>
@@ -3446,7 +3514,7 @@
               </a:rPr>
               <a:t>ШАГ 2 · КОНСТРУКЦИЯ</a:t>
             </a:r>
-            <a:endParaRPr lang="en-US" sz="1200"/>
+            <a:endParaRPr lang="en-US" sz="1200" noProof="1"/>
           </a:p>
         </p:txBody>
       </p:sp>
@@ -3479,7 +3547,7 @@
               </a:lnSpc>
             </a:pPr>
             <a:r>
-              <a:rPr lang="en-US" sz="3000" b="1">
+              <a:rPr lang="en-US" sz="3000" noProof="1" b="1">
                 <a:solidFill>
                   <a:srgbClr val="000000"/>
                 </a:solidFill>
@@ -3488,7 +3556,7 @@
               </a:rPr>
               <a:t>Соберите «пирог» покрытия</a:t>
             </a:r>
-            <a:endParaRPr lang="en-US" sz="3000"/>
+            <a:endParaRPr lang="en-US" sz="3000" noProof="1"/>
           </a:p>
         </p:txBody>
       </p:sp>
@@ -3565,7 +3633,7 @@
               </a:lnSpc>
             </a:pPr>
             <a:r>
-              <a:rPr lang="en-US" sz="1300" b="1">
+              <a:rPr lang="en-US" sz="1300" noProof="1" b="1">
                 <a:solidFill>
                   <a:srgbClr val="4E4E4E"/>
                 </a:solidFill>
@@ -3575,16 +3643,16 @@
               <a:t>Начните с шаблона</a:t>
             </a:r>
             <a:r>
-              <a:rPr lang="en-US" sz="1300">
-                <a:solidFill>
-                  <a:srgbClr val="4E4E4E"/>
-                </a:solidFill>
-                <a:latin typeface="MiSans"/>
-                <a:ea typeface="MiSans"/>
-              </a:rPr>
-              <a:t> — 4 готовых: парковка, дорога, пешеходная зона, въезд/пандус</a:t>
-            </a:r>
-            <a:endParaRPr lang="en-US" sz="1300"/>
+              <a:rPr lang="en-US" sz="1300" noProof="1">
+                <a:solidFill>
+                  <a:srgbClr val="4E4E4E"/>
+                </a:solidFill>
+                <a:latin typeface="MiSans"/>
+                <a:ea typeface="MiSans"/>
+              </a:rPr>
+              <a:t> — 3 готовых: парковка/площадка (бетон), пешеходная дорожка (плитка), въезд в гараж/пандус</a:t>
+            </a:r>
+            <a:endParaRPr lang="en-US" sz="1300" noProof="1"/>
           </a:p>
         </p:txBody>
       </p:sp>
@@ -3639,7 +3707,7 @@
               </a:lnSpc>
             </a:pPr>
             <a:r>
-              <a:rPr lang="en-US" sz="1300" b="1">
+              <a:rPr lang="en-US" sz="1300" noProof="1" b="1">
                 <a:solidFill>
                   <a:srgbClr val="4E4E4E"/>
                 </a:solidFill>
@@ -3649,7 +3717,7 @@
               <a:t>Или соберите свои слои</a:t>
             </a:r>
             <a:r>
-              <a:rPr lang="en-US" sz="1300">
+              <a:rPr lang="en-US" sz="1300" noProof="1">
                 <a:solidFill>
                   <a:srgbClr val="4E4E4E"/>
                 </a:solidFill>
@@ -3658,7 +3726,7 @@
               </a:rPr>
               <a:t> — 15 материалов, толщина каждого 10–1000 мм</a:t>
             </a:r>
-            <a:endParaRPr lang="en-US" sz="1300"/>
+            <a:endParaRPr lang="en-US" sz="1300" noProof="1"/>
           </a:p>
         </p:txBody>
       </p:sp>
@@ -3713,7 +3781,7 @@
               </a:lnSpc>
             </a:pPr>
             <a:r>
-              <a:rPr lang="en-US" sz="1300" b="1">
+              <a:rPr lang="en-US" sz="1300" noProof="1" b="1">
                 <a:solidFill>
                   <a:srgbClr val="4E4E4E"/>
                 </a:solidFill>
@@ -3723,7 +3791,7 @@
               <a:t>Укажите УГВ</a:t>
             </a:r>
             <a:r>
-              <a:rPr lang="en-US" sz="1300">
+              <a:rPr lang="en-US" sz="1300" noProof="1">
                 <a:solidFill>
                   <a:srgbClr val="4E4E4E"/>
                 </a:solidFill>
@@ -3732,7 +3800,7 @@
               </a:rPr>
               <a:t> — при грунтовых водах выше 1 м λ слоёв под трубой меняется на «влажную»</a:t>
             </a:r>
-            <a:endParaRPr lang="en-US" sz="1300"/>
+            <a:endParaRPr lang="en-US" sz="1300" noProof="1"/>
           </a:p>
         </p:txBody>
       </p:sp>
@@ -3787,7 +3855,7 @@
               </a:lnSpc>
             </a:pPr>
             <a:r>
-              <a:rPr lang="en-US" sz="1300" b="1">
+              <a:rPr lang="en-US" sz="1300" noProof="1" b="1">
                 <a:solidFill>
                   <a:srgbClr val="4E4E4E"/>
                 </a:solidFill>
@@ -3797,7 +3865,7 @@
               <a:t>Следите за разрезом справа</a:t>
             </a:r>
             <a:r>
-              <a:rPr lang="en-US" sz="1300">
+              <a:rPr lang="en-US" sz="1300" noProof="1">
                 <a:solidFill>
                   <a:srgbClr val="4E4E4E"/>
                 </a:solidFill>
@@ -3806,7 +3874,7 @@
               </a:rPr>
               <a:t> — визуализация и значения R₁, R₂, λE пересчитываются сразу</a:t>
             </a:r>
-            <a:endParaRPr lang="en-US" sz="1300"/>
+            <a:endParaRPr lang="en-US" sz="1300" noProof="1"/>
           </a:p>
         </p:txBody>
       </p:sp>
@@ -3839,7 +3907,7 @@
               </a:lnSpc>
             </a:pPr>
             <a:r>
-              <a:rPr lang="en-US" sz="1200">
+              <a:rPr lang="en-US" sz="1200" noProof="1">
                 <a:solidFill>
                   <a:srgbClr val="818181"/>
                 </a:solidFill>
@@ -3848,7 +3916,7 @@
               </a:rPr>
               <a:t>Помните: над трубой минимум 40 мм (без нагрузок) или 50 мм (с нагрузками). Для бетона t подачи не выше 50 °C</a:t>
             </a:r>
-            <a:endParaRPr lang="en-US" sz="1200"/>
+            <a:endParaRPr lang="en-US" sz="1200" noProof="1"/>
           </a:p>
         </p:txBody>
       </p:sp>
@@ -3936,7 +4004,7 @@
               </a:lnSpc>
             </a:pPr>
             <a:r>
-              <a:rPr lang="en-US" sz="1100">
+              <a:rPr lang="en-US" sz="1100" noProof="1">
                 <a:solidFill>
                   <a:srgbClr val="818181"/>
                 </a:solidFill>
@@ -3945,7 +4013,7 @@
               </a:rPr>
               <a:t>Шаг «Конструкция» — слои и живой разрез «пирога»</a:t>
             </a:r>
-            <a:endParaRPr lang="en-US" sz="1100"/>
+            <a:endParaRPr lang="en-US" sz="1100" noProof="1"/>
           </a:p>
         </p:txBody>
       </p:sp>
@@ -4004,7 +4072,7 @@
               </a:lnSpc>
             </a:pPr>
             <a:r>
-              <a:rPr lang="en-US" sz="1100">
+              <a:rPr lang="en-US" sz="1100" noProof="1">
                 <a:solidFill>
                   <a:srgbClr val="818181"/>
                 </a:solidFill>
@@ -4013,7 +4081,7 @@
               </a:rPr>
               <a:t>05</a:t>
             </a:r>
-            <a:endParaRPr lang="en-US" sz="1100"/>
+            <a:endParaRPr lang="en-US" sz="1100" noProof="1"/>
           </a:p>
         </p:txBody>
       </p:sp>
@@ -4081,7 +4149,7 @@
               </a:lnSpc>
             </a:pPr>
             <a:r>
-              <a:rPr lang="en-US" sz="1200" b="1" spc="200" kern="0">
+              <a:rPr lang="en-US" sz="1200" noProof="1" b="1" spc="200" kern="0">
                 <a:solidFill>
                   <a:srgbClr val="E50040"/>
                 </a:solidFill>
@@ -4090,7 +4158,7 @@
               </a:rPr>
               <a:t>ШАГ 3 · ТЕПЛОВОЙ РАСЧЁТ</a:t>
             </a:r>
-            <a:endParaRPr lang="en-US" sz="1200"/>
+            <a:endParaRPr lang="en-US" sz="1200" noProof="1"/>
           </a:p>
         </p:txBody>
       </p:sp>
@@ -4123,7 +4191,7 @@
               </a:lnSpc>
             </a:pPr>
             <a:r>
-              <a:rPr lang="en-US" sz="3000" b="1">
+              <a:rPr lang="en-US" sz="3000" noProof="1" b="1">
                 <a:solidFill>
                   <a:srgbClr val="000000"/>
                 </a:solidFill>
@@ -4132,7 +4200,7 @@
               </a:rPr>
               <a:t>Подберите мощность</a:t>
             </a:r>
-            <a:endParaRPr lang="en-US" sz="3000"/>
+            <a:endParaRPr lang="en-US" sz="3000" noProof="1"/>
           </a:p>
         </p:txBody>
       </p:sp>
@@ -4209,7 +4277,7 @@
               </a:lnSpc>
             </a:pPr>
             <a:r>
-              <a:rPr lang="en-US" sz="1300" b="1">
+              <a:rPr lang="en-US" sz="1300" noProof="1" b="1">
                 <a:solidFill>
                   <a:srgbClr val="4E4E4E"/>
                 </a:solidFill>
@@ -4219,7 +4287,7 @@
               <a:t>Выберите режим</a:t>
             </a:r>
             <a:r>
-              <a:rPr lang="en-US" sz="1300">
+              <a:rPr lang="en-US" sz="1300" noProof="1">
                 <a:solidFill>
                   <a:srgbClr val="4E4E4E"/>
                 </a:solidFill>
@@ -4228,7 +4296,7 @@
               </a:rPr>
               <a:t> — Melting (таяние, поверхность +5 °C) для большинства объектов</a:t>
             </a:r>
-            <a:endParaRPr lang="en-US" sz="1300"/>
+            <a:endParaRPr lang="en-US" sz="1300" noProof="1"/>
           </a:p>
         </p:txBody>
       </p:sp>
@@ -4283,7 +4351,7 @@
               </a:lnSpc>
             </a:pPr>
             <a:r>
-              <a:rPr lang="en-US" sz="1300" b="1">
+              <a:rPr lang="en-US" sz="1300" noProof="1" b="1">
                 <a:solidFill>
                   <a:srgbClr val="4E4E4E"/>
                 </a:solidFill>
@@ -4293,7 +4361,7 @@
               <a:t>Выберите трубу и шаг укладки</a:t>
             </a:r>
             <a:r>
-              <a:rPr lang="en-US" sz="1300">
+              <a:rPr lang="en-US" sz="1300" noProof="1">
                 <a:solidFill>
                   <a:srgbClr val="4E4E4E"/>
                 </a:solidFill>
@@ -4302,7 +4370,7 @@
               </a:rPr>
               <a:t> — RAUTHERM S 17/20/25 мм, чем меньше шаг, тем выше мощность</a:t>
             </a:r>
-            <a:endParaRPr lang="en-US" sz="1300"/>
+            <a:endParaRPr lang="en-US" sz="1300" noProof="1"/>
           </a:p>
         </p:txBody>
       </p:sp>
@@ -4357,7 +4425,7 @@
               </a:lnSpc>
             </a:pPr>
             <a:r>
-              <a:rPr lang="en-US" sz="1300" b="1">
+              <a:rPr lang="en-US" sz="1300" noProof="1" b="1">
                 <a:solidFill>
                   <a:srgbClr val="4E4E4E"/>
                 </a:solidFill>
@@ -4367,7 +4435,7 @@
               <a:t>Нажмите «Рассчитать»</a:t>
             </a:r>
             <a:r>
-              <a:rPr lang="en-US" sz="1300">
+              <a:rPr lang="en-US" sz="1300" noProof="1">
                 <a:solidFill>
                   <a:srgbClr val="4E4E4E"/>
                 </a:solidFill>
@@ -4376,7 +4444,7 @@
               </a:rPr>
               <a:t> — увидите поток вверх q↑, вниз q↓ и суммарную мощность</a:t>
             </a:r>
-            <a:endParaRPr lang="en-US" sz="1300"/>
+            <a:endParaRPr lang="en-US" sz="1300" noProof="1"/>
           </a:p>
         </p:txBody>
       </p:sp>
@@ -4431,7 +4499,7 @@
               </a:lnSpc>
             </a:pPr>
             <a:r>
-              <a:rPr lang="en-US" sz="1300" b="1">
+              <a:rPr lang="en-US" sz="1300" noProof="1" b="1">
                 <a:solidFill>
                   <a:srgbClr val="4E4E4E"/>
                 </a:solidFill>
@@ -4441,7 +4509,7 @@
               <a:t>Сверьтесь с подсказкой</a:t>
             </a:r>
             <a:r>
-              <a:rPr lang="en-US" sz="1300">
+              <a:rPr lang="en-US" sz="1300" noProof="1">
                 <a:solidFill>
                   <a:srgbClr val="4E4E4E"/>
                 </a:solidFill>
@@ -4450,7 +4518,7 @@
               </a:rPr>
               <a:t> — программа рекомендует температуру подачи под ΔT = 15 K</a:t>
             </a:r>
-            <a:endParaRPr lang="en-US" sz="1300"/>
+            <a:endParaRPr lang="en-US" sz="1300" noProof="1"/>
           </a:p>
         </p:txBody>
       </p:sp>
@@ -4483,7 +4551,7 @@
               </a:lnSpc>
             </a:pPr>
             <a:r>
-              <a:rPr lang="en-US" sz="1200">
+              <a:rPr lang="en-US" sz="1200" noProof="1">
                 <a:solidFill>
                   <a:srgbClr val="818181"/>
                 </a:solidFill>
@@ -4492,7 +4560,7 @@
               </a:rPr>
               <a:t>Ориентир: длина одного контура Ø20 не должна превышать 120 м — заложите это при разбивке на контуры</a:t>
             </a:r>
-            <a:endParaRPr lang="en-US" sz="1200"/>
+            <a:endParaRPr lang="en-US" sz="1200" noProof="1"/>
           </a:p>
         </p:txBody>
       </p:sp>
@@ -4580,7 +4648,7 @@
               </a:lnSpc>
             </a:pPr>
             <a:r>
-              <a:rPr lang="en-US" sz="1100">
+              <a:rPr lang="en-US" sz="1100" noProof="1">
                 <a:solidFill>
                   <a:srgbClr val="818181"/>
                 </a:solidFill>
@@ -4589,7 +4657,7 @@
               </a:rPr>
               <a:t>Шаг «Тепловой расчёт» — результаты после кнопки «Рассчитать»</a:t>
             </a:r>
-            <a:endParaRPr lang="en-US" sz="1100"/>
+            <a:endParaRPr lang="en-US" sz="1100" noProof="1"/>
           </a:p>
         </p:txBody>
       </p:sp>
@@ -4648,7 +4716,7 @@
               </a:lnSpc>
             </a:pPr>
             <a:r>
-              <a:rPr lang="en-US" sz="1100">
+              <a:rPr lang="en-US" sz="1100" noProof="1">
                 <a:solidFill>
                   <a:srgbClr val="818181"/>
                 </a:solidFill>
@@ -4657,7 +4725,7 @@
               </a:rPr>
               <a:t>06</a:t>
             </a:r>
-            <a:endParaRPr lang="en-US" sz="1100"/>
+            <a:endParaRPr lang="en-US" sz="1100" noProof="1"/>
           </a:p>
         </p:txBody>
       </p:sp>
@@ -4725,7 +4793,7 @@
               </a:lnSpc>
             </a:pPr>
             <a:r>
-              <a:rPr lang="en-US" sz="1200" b="1" spc="200" kern="0">
+              <a:rPr lang="en-US" sz="1200" noProof="1" b="1" spc="200" kern="0">
                 <a:solidFill>
                   <a:srgbClr val="E50040"/>
                 </a:solidFill>
@@ -4734,7 +4802,7 @@
               </a:rPr>
               <a:t>ШАГ 4 · ГИДРАВЛИКА</a:t>
             </a:r>
-            <a:endParaRPr lang="en-US" sz="1200"/>
+            <a:endParaRPr lang="en-US" sz="1200" noProof="1"/>
           </a:p>
         </p:txBody>
       </p:sp>
@@ -4767,7 +4835,7 @@
               </a:lnSpc>
             </a:pPr>
             <a:r>
-              <a:rPr lang="en-US" sz="3000" b="1">
+              <a:rPr lang="en-US" sz="3000" noProof="1" b="1">
                 <a:solidFill>
                   <a:srgbClr val="000000"/>
                 </a:solidFill>
@@ -4776,7 +4844,7 @@
               </a:rPr>
               <a:t>Разбейте систему на контуры</a:t>
             </a:r>
-            <a:endParaRPr lang="en-US" sz="3000"/>
+            <a:endParaRPr lang="en-US" sz="3000" noProof="1"/>
           </a:p>
         </p:txBody>
       </p:sp>
@@ -4853,7 +4921,7 @@
               </a:lnSpc>
             </a:pPr>
             <a:r>
-              <a:rPr lang="en-US" sz="1300" b="1">
+              <a:rPr lang="en-US" sz="1300" noProof="1" b="1">
                 <a:solidFill>
                   <a:srgbClr val="4E4E4E"/>
                 </a:solidFill>
@@ -4863,7 +4931,7 @@
               <a:t>Задайте теплоноситель</a:t>
             </a:r>
             <a:r>
-              <a:rPr lang="en-US" sz="1300">
+              <a:rPr lang="en-US" sz="1300" noProof="1">
                 <a:solidFill>
                   <a:srgbClr val="4E4E4E"/>
                 </a:solidFill>
@@ -4872,7 +4940,7 @@
               </a:rPr>
               <a:t> — тип гликоля и концентрацию; свойства подтянутся из базы ASHRAE</a:t>
             </a:r>
-            <a:endParaRPr lang="en-US" sz="1300"/>
+            <a:endParaRPr lang="en-US" sz="1300" noProof="1"/>
           </a:p>
         </p:txBody>
       </p:sp>
@@ -4927,7 +4995,7 @@
               </a:lnSpc>
             </a:pPr>
             <a:r>
-              <a:rPr lang="en-US" sz="1300" b="1">
+              <a:rPr lang="en-US" sz="1300" noProof="1" b="1">
                 <a:solidFill>
                   <a:srgbClr val="4E4E4E"/>
                 </a:solidFill>
@@ -4937,7 +5005,7 @@
               <a:t>Добавьте коллекторы и контуры</a:t>
             </a:r>
             <a:r>
-              <a:rPr lang="en-US" sz="1300">
+              <a:rPr lang="en-US" sz="1300" noProof="1">
                 <a:solidFill>
                   <a:srgbClr val="4E4E4E"/>
                 </a:solidFill>
@@ -4946,7 +5014,7 @@
               </a:rPr>
               <a:t> — длина каждого контура и подводки</a:t>
             </a:r>
-            <a:endParaRPr lang="en-US" sz="1300"/>
+            <a:endParaRPr lang="en-US" sz="1300" noProof="1"/>
           </a:p>
         </p:txBody>
       </p:sp>
@@ -5001,7 +5069,7 @@
               </a:lnSpc>
             </a:pPr>
             <a:r>
-              <a:rPr lang="en-US" sz="1300" b="1">
+              <a:rPr lang="en-US" sz="1300" noProof="1" b="1">
                 <a:solidFill>
                   <a:srgbClr val="4E4E4E"/>
                 </a:solidFill>
@@ -5011,7 +5079,7 @@
               <a:t>Нажмите «Рассчитать»</a:t>
             </a:r>
             <a:r>
-              <a:rPr lang="en-US" sz="1300">
+              <a:rPr lang="en-US" sz="1300" noProof="1">
                 <a:solidFill>
                   <a:srgbClr val="4E4E4E"/>
                 </a:solidFill>
@@ -5020,7 +5088,7 @@
               </a:rPr>
               <a:t> — расходы, скорости и потери давления по каждому контуру</a:t>
             </a:r>
-            <a:endParaRPr lang="en-US" sz="1300"/>
+            <a:endParaRPr lang="en-US" sz="1300" noProof="1"/>
           </a:p>
         </p:txBody>
       </p:sp>
@@ -5075,7 +5143,7 @@
               </a:lnSpc>
             </a:pPr>
             <a:r>
-              <a:rPr lang="en-US" sz="1300" b="1">
+              <a:rPr lang="en-US" sz="1300" noProof="1" b="1">
                 <a:solidFill>
                   <a:srgbClr val="4E4E4E"/>
                 </a:solidFill>
@@ -5085,7 +5153,7 @@
               <a:t>Проверьте балансировку</a:t>
             </a:r>
             <a:r>
-              <a:rPr lang="en-US" sz="1300">
+              <a:rPr lang="en-US" sz="1300" noProof="1">
                 <a:solidFill>
                   <a:srgbClr val="4E4E4E"/>
                 </a:solidFill>
@@ -5094,7 +5162,7 @@
               </a:rPr>
               <a:t> — программа выдаст дросселирование и обороты вентилей для монтажа</a:t>
             </a:r>
-            <a:endParaRPr lang="en-US" sz="1300"/>
+            <a:endParaRPr lang="en-US" sz="1300" noProof="1"/>
           </a:p>
         </p:txBody>
       </p:sp>
@@ -5127,7 +5195,7 @@
               </a:lnSpc>
             </a:pPr>
             <a:r>
-              <a:rPr lang="en-US" sz="1200">
+              <a:rPr lang="en-US" sz="1200" noProof="1">
                 <a:solidFill>
                   <a:srgbClr val="818181"/>
                 </a:solidFill>
@@ -5136,7 +5204,7 @@
               </a:rPr>
               <a:t>Максимально допустимые потери на коллектор — 320 мбар; программа предупредит, если подбор не сошёлся</a:t>
             </a:r>
-            <a:endParaRPr lang="en-US" sz="1200"/>
+            <a:endParaRPr lang="en-US" sz="1200" noProof="1"/>
           </a:p>
         </p:txBody>
       </p:sp>
@@ -5224,7 +5292,7 @@
               </a:lnSpc>
             </a:pPr>
             <a:r>
-              <a:rPr lang="en-US" sz="1100">
+              <a:rPr lang="en-US" sz="1100" noProof="1">
                 <a:solidFill>
                   <a:srgbClr val="818181"/>
                 </a:solidFill>
@@ -5233,7 +5301,7 @@
               </a:rPr>
               <a:t>Шаг «Гидравлика» — таблица контуров по коллекторам</a:t>
             </a:r>
-            <a:endParaRPr lang="en-US" sz="1100"/>
+            <a:endParaRPr lang="en-US" sz="1100" noProof="1"/>
           </a:p>
         </p:txBody>
       </p:sp>
@@ -5292,7 +5360,7 @@
               </a:lnSpc>
             </a:pPr>
             <a:r>
-              <a:rPr lang="en-US" sz="1100">
+              <a:rPr lang="en-US" sz="1100" noProof="1">
                 <a:solidFill>
                   <a:srgbClr val="818181"/>
                 </a:solidFill>
@@ -5301,7 +5369,7 @@
               </a:rPr>
               <a:t>07</a:t>
             </a:r>
-            <a:endParaRPr lang="en-US" sz="1100"/>
+            <a:endParaRPr lang="en-US" sz="1100" noProof="1"/>
           </a:p>
         </p:txBody>
       </p:sp>
@@ -5369,7 +5437,7 @@
               </a:lnSpc>
             </a:pPr>
             <a:r>
-              <a:rPr lang="en-US" sz="1200" b="1" spc="200" kern="0">
+              <a:rPr lang="en-US" sz="1200" noProof="1" b="1" spc="200" kern="0">
                 <a:solidFill>
                   <a:srgbClr val="E50040"/>
                 </a:solidFill>
@@ -5378,7 +5446,7 @@
               </a:rPr>
               <a:t>ШАГ 5 · РЕЗУЛЬТАТЫ</a:t>
             </a:r>
-            <a:endParaRPr lang="en-US" sz="1200"/>
+            <a:endParaRPr lang="en-US" sz="1200" noProof="1"/>
           </a:p>
         </p:txBody>
       </p:sp>
@@ -5411,7 +5479,7 @@
               </a:lnSpc>
             </a:pPr>
             <a:r>
-              <a:rPr lang="en-US" sz="3000" b="1">
+              <a:rPr lang="en-US" sz="3000" noProof="1" b="1">
                 <a:solidFill>
                   <a:srgbClr val="000000"/>
                 </a:solidFill>
@@ -5420,7 +5488,7 @@
               </a:rPr>
               <a:t>Проверьте и выгрузите</a:t>
             </a:r>
-            <a:endParaRPr lang="en-US" sz="3000"/>
+            <a:endParaRPr lang="en-US" sz="3000" noProof="1"/>
           </a:p>
         </p:txBody>
       </p:sp>
@@ -5497,7 +5565,7 @@
               </a:lnSpc>
             </a:pPr>
             <a:r>
-              <a:rPr lang="en-US" sz="1300" b="1">
+              <a:rPr lang="en-US" sz="1300" noProof="1" b="1">
                 <a:solidFill>
                   <a:srgbClr val="4E4E4E"/>
                 </a:solidFill>
@@ -5507,7 +5575,7 @@
               <a:t>Сверьте КПИ в шапке</a:t>
             </a:r>
             <a:r>
-              <a:rPr lang="en-US" sz="1300">
+              <a:rPr lang="en-US" sz="1300" noProof="1">
                 <a:solidFill>
                   <a:srgbClr val="4E4E4E"/>
                 </a:solidFill>
@@ -5516,7 +5584,7 @@
               </a:rPr>
               <a:t> — мощность, объём, насос, температуры подачи и обратки</a:t>
             </a:r>
-            <a:endParaRPr lang="en-US" sz="1300"/>
+            <a:endParaRPr lang="en-US" sz="1300" noProof="1"/>
           </a:p>
         </p:txBody>
       </p:sp>
@@ -5571,7 +5639,7 @@
               </a:lnSpc>
             </a:pPr>
             <a:r>
-              <a:rPr lang="en-US" sz="1300" b="1">
+              <a:rPr lang="en-US" sz="1300" noProof="1" b="1">
                 <a:solidFill>
                   <a:srgbClr val="4E4E4E"/>
                 </a:solidFill>
@@ -5581,7 +5649,7 @@
               <a:t>Проверьте ведомость</a:t>
             </a:r>
             <a:r>
-              <a:rPr lang="en-US" sz="1300">
+              <a:rPr lang="en-US" sz="1300" noProof="1">
                 <a:solidFill>
                   <a:srgbClr val="4E4E4E"/>
                 </a:solidFill>
@@ -5590,7 +5658,7 @@
               </a:rPr>
               <a:t> — коллекторы, труба, бак: это будущая спецификация заказа</a:t>
             </a:r>
-            <a:endParaRPr lang="en-US" sz="1300"/>
+            <a:endParaRPr lang="en-US" sz="1300" noProof="1"/>
           </a:p>
         </p:txBody>
       </p:sp>
@@ -5645,7 +5713,7 @@
               </a:lnSpc>
             </a:pPr>
             <a:r>
-              <a:rPr lang="en-US" sz="1300" b="1">
+              <a:rPr lang="en-US" sz="1300" noProof="1" b="1">
                 <a:solidFill>
                   <a:srgbClr val="4E4E4E"/>
                 </a:solidFill>
@@ -5655,7 +5723,7 @@
               <a:t>Сохраните проект</a:t>
             </a:r>
             <a:r>
-              <a:rPr lang="en-US" sz="1300">
+              <a:rPr lang="en-US" sz="1300" noProof="1">
                 <a:solidFill>
                   <a:srgbClr val="4E4E4E"/>
                 </a:solidFill>
@@ -5664,7 +5732,7 @@
               </a:rPr>
               <a:t> — файл .smc откроется позже со всеми введёнными данными</a:t>
             </a:r>
-            <a:endParaRPr lang="en-US" sz="1300"/>
+            <a:endParaRPr lang="en-US" sz="1300" noProof="1"/>
           </a:p>
         </p:txBody>
       </p:sp>
@@ -5719,7 +5787,7 @@
               </a:lnSpc>
             </a:pPr>
             <a:r>
-              <a:rPr lang="en-US" sz="1300" b="1">
+              <a:rPr lang="en-US" sz="1300" noProof="1" b="1">
                 <a:solidFill>
                   <a:srgbClr val="4E4E4E"/>
                 </a:solidFill>
@@ -5729,7 +5797,7 @@
               <a:t>Выгрузите отчёт</a:t>
             </a:r>
             <a:r>
-              <a:rPr lang="en-US" sz="1300">
+              <a:rPr lang="en-US" sz="1300" noProof="1">
                 <a:solidFill>
                   <a:srgbClr val="4E4E4E"/>
                 </a:solidFill>
@@ -5738,7 +5806,7 @@
               </a:rPr>
               <a:t> — «Предпросмотр» или «Печать» дадут брендированный PDF для заказчика</a:t>
             </a:r>
-            <a:endParaRPr lang="en-US" sz="1300"/>
+            <a:endParaRPr lang="en-US" sz="1300" noProof="1"/>
           </a:p>
         </p:txBody>
       </p:sp>
@@ -5771,7 +5839,7 @@
               </a:lnSpc>
             </a:pPr>
             <a:r>
-              <a:rPr lang="en-US" sz="1200">
+              <a:rPr lang="en-US" sz="1200" noProof="1">
                 <a:solidFill>
                   <a:srgbClr val="818181"/>
                 </a:solidFill>
@@ -5780,7 +5848,7 @@
               </a:rPr>
               <a:t>Обороты вентилей из отчёта передайте монтажникам — это настройки балансировки на объекте</a:t>
             </a:r>
-            <a:endParaRPr lang="en-US" sz="1200"/>
+            <a:endParaRPr lang="en-US" sz="1200" noProof="1"/>
           </a:p>
         </p:txBody>
       </p:sp>
@@ -5868,7 +5936,7 @@
               </a:lnSpc>
             </a:pPr>
             <a:r>
-              <a:rPr lang="en-US" sz="1100">
+              <a:rPr lang="en-US" sz="1100" noProof="1">
                 <a:solidFill>
                   <a:srgbClr val="818181"/>
                 </a:solidFill>
@@ -5877,7 +5945,7 @@
               </a:rPr>
               <a:t>Шаг «Результаты» — КПИ, оборудование и исходные данные</a:t>
             </a:r>
-            <a:endParaRPr lang="en-US" sz="1100"/>
+            <a:endParaRPr lang="en-US" sz="1100" noProof="1"/>
           </a:p>
         </p:txBody>
       </p:sp>
@@ -5936,7 +6004,7 @@
               </a:lnSpc>
             </a:pPr>
             <a:r>
-              <a:rPr lang="en-US" sz="1100">
+              <a:rPr lang="en-US" sz="1100" noProof="1">
                 <a:solidFill>
                   <a:srgbClr val="818181"/>
                 </a:solidFill>
@@ -5945,7 +6013,7 @@
               </a:rPr>
               <a:t>08</a:t>
             </a:r>
-            <a:endParaRPr lang="en-US" sz="1100"/>
+            <a:endParaRPr lang="en-US" sz="1100" noProof="1"/>
           </a:p>
         </p:txBody>
       </p:sp>
@@ -6013,7 +6081,7 @@
               </a:lnSpc>
             </a:pPr>
             <a:r>
-              <a:rPr lang="en-US" sz="1200" b="1" spc="200" kern="0">
+              <a:rPr lang="en-US" sz="1200" noProof="1" b="1" spc="200" kern="0">
                 <a:solidFill>
                   <a:srgbClr val="E50040"/>
                 </a:solidFill>
@@ -6022,7 +6090,7 @@
               </a:rPr>
               <a:t>ПОЛЕЗНО ЗНАТЬ</a:t>
             </a:r>
-            <a:endParaRPr lang="en-US" sz="1200"/>
+            <a:endParaRPr lang="en-US" sz="1200" noProof="1"/>
           </a:p>
         </p:txBody>
       </p:sp>
@@ -6055,7 +6123,7 @@
               </a:lnSpc>
             </a:pPr>
             <a:r>
-              <a:rPr lang="en-US" sz="3000" b="1">
+              <a:rPr lang="en-US" sz="3000" noProof="1" b="1">
                 <a:solidFill>
                   <a:srgbClr val="000000"/>
                 </a:solidFill>
@@ -6064,7 +6132,7 @@
               </a:rPr>
               <a:t>Бейджи и типичные ошибки</a:t>
             </a:r>
-            <a:endParaRPr lang="en-US" sz="3000"/>
+            <a:endParaRPr lang="en-US" sz="3000" noProof="1"/>
           </a:p>
         </p:txBody>
       </p:sp>
@@ -6145,7 +6213,7 @@
               </a:lnSpc>
             </a:pPr>
             <a:r>
-              <a:rPr lang="en-US" sz="1600" b="1">
+              <a:rPr lang="en-US" sz="1600" noProof="1" b="1">
                 <a:solidFill>
                   <a:srgbClr val="000000"/>
                 </a:solidFill>
@@ -6154,7 +6222,7 @@
               </a:rPr>
               <a:t>Как читать бейджи шагов</a:t>
             </a:r>
-            <a:endParaRPr lang="en-US" sz="1600"/>
+            <a:endParaRPr lang="en-US" sz="1600" noProof="1"/>
           </a:p>
         </p:txBody>
       </p:sp>
@@ -6211,7 +6279,7 @@
               </a:lnSpc>
             </a:pPr>
             <a:r>
-              <a:rPr lang="en-US" sz="1300" b="1">
+              <a:rPr lang="en-US" sz="1300" noProof="1" b="1">
                 <a:solidFill>
                   <a:srgbClr val="4E4E4E"/>
                 </a:solidFill>
@@ -6221,7 +6289,7 @@
               <a:t>Зелёный</a:t>
             </a:r>
             <a:r>
-              <a:rPr lang="en-US" sz="1300">
+              <a:rPr lang="en-US" sz="1300" noProof="1">
                 <a:solidFill>
                   <a:srgbClr val="4E4E4E"/>
                 </a:solidFill>
@@ -6230,7 +6298,7 @@
               </a:rPr>
               <a:t> — данные шага актуальны, можно идти дальше</a:t>
             </a:r>
-            <a:endParaRPr lang="en-US" sz="1300"/>
+            <a:endParaRPr lang="en-US" sz="1300" noProof="1"/>
           </a:p>
         </p:txBody>
       </p:sp>
@@ -6287,7 +6355,7 @@
               </a:lnSpc>
             </a:pPr>
             <a:r>
-              <a:rPr lang="en-US" sz="1300" b="1">
+              <a:rPr lang="en-US" sz="1300" noProof="1" b="1">
                 <a:solidFill>
                   <a:srgbClr val="4E4E4E"/>
                 </a:solidFill>
@@ -6297,7 +6365,7 @@
               <a:t>Красный</a:t>
             </a:r>
             <a:r>
-              <a:rPr lang="en-US" sz="1300">
+              <a:rPr lang="en-US" sz="1300" noProof="1">
                 <a:solidFill>
                   <a:srgbClr val="4E4E4E"/>
                 </a:solidFill>
@@ -6306,7 +6374,7 @@
               </a:rPr>
               <a:t> — параметры изменились: вернитесь на шаг и нажмите «Рассчитать»</a:t>
             </a:r>
-            <a:endParaRPr lang="en-US" sz="1300"/>
+            <a:endParaRPr lang="en-US" sz="1300" noProof="1"/>
           </a:p>
         </p:txBody>
       </p:sp>
@@ -6339,7 +6407,7 @@
               </a:lnSpc>
             </a:pPr>
             <a:r>
-              <a:rPr lang="en-US" sz="1200">
+              <a:rPr lang="en-US" sz="1200" noProof="1">
                 <a:solidFill>
                   <a:srgbClr val="818181"/>
                 </a:solidFill>
@@ -6348,7 +6416,7 @@
               </a:rPr>
               <a:t>Программа не даёт «уйти вперёд» с устаревшими данными: перед выгрузкой отчёта все бейджи должны быть зелёными</a:t>
             </a:r>
-            <a:endParaRPr lang="en-US" sz="1200"/>
+            <a:endParaRPr lang="en-US" sz="1200" noProof="1"/>
           </a:p>
         </p:txBody>
       </p:sp>
@@ -6407,7 +6475,7 @@
               </a:lnSpc>
             </a:pPr>
             <a:r>
-              <a:rPr lang="en-US" sz="1600" b="1">
+              <a:rPr lang="en-US" sz="1600" noProof="1" b="1">
                 <a:solidFill>
                   <a:srgbClr val="000000"/>
                 </a:solidFill>
@@ -6416,7 +6484,7 @@
               </a:rPr>
               <a:t>Частые ошибки новичков</a:t>
             </a:r>
-            <a:endParaRPr lang="en-US" sz="1600"/>
+            <a:endParaRPr lang="en-US" sz="1600" noProof="1"/>
           </a:p>
         </p:txBody>
       </p:sp>
@@ -6449,7 +6517,7 @@
               </a:lnSpc>
             </a:pPr>
             <a:r>
-              <a:rPr lang="en-US" sz="1300">
+              <a:rPr lang="en-US" sz="1300" noProof="1">
                 <a:solidFill>
                   <a:srgbClr val="4E4E4E"/>
                 </a:solidFill>
@@ -6458,7 +6526,7 @@
               </a:rPr>
               <a:t>Забыли нажать «Рассчитать» после правки — смотрите на красный бейдж</a:t>
             </a:r>
-            <a:endParaRPr lang="en-US" sz="1300"/>
+            <a:endParaRPr lang="en-US" sz="1300" noProof="1"/>
           </a:p>
           <a:p>
             <a:pPr algn="l">
@@ -6470,7 +6538,7 @@
               </a:spcBef>
             </a:pPr>
             <a:r>
-              <a:rPr lang="en-US" sz="1300">
+              <a:rPr lang="en-US" sz="1300" noProof="1">
                 <a:solidFill>
                   <a:srgbClr val="4E4E4E"/>
                 </a:solidFill>
@@ -6479,7 +6547,7 @@
               </a:rPr>
               <a:t>Асфальт при t ниже −15 °C — выберите бетон или плитку</a:t>
             </a:r>
-            <a:endParaRPr lang="en-US" sz="1300"/>
+            <a:endParaRPr lang="en-US" sz="1300" noProof="1"/>
           </a:p>
           <a:p>
             <a:pPr algn="l">
@@ -6491,7 +6559,7 @@
               </a:spcBef>
             </a:pPr>
             <a:r>
-              <a:rPr lang="en-US" sz="1300">
+              <a:rPr lang="en-US" sz="1300" noProof="1">
                 <a:solidFill>
                   <a:srgbClr val="4E4E4E"/>
                 </a:solidFill>
@@ -6500,7 +6568,7 @@
               </a:rPr>
               <a:t>Подача выше 50 °C для бетона — снизьте температуру</a:t>
             </a:r>
-            <a:endParaRPr lang="en-US" sz="1300"/>
+            <a:endParaRPr lang="en-US" sz="1300" noProof="1"/>
           </a:p>
           <a:p>
             <a:pPr algn="l">
@@ -6512,7 +6580,7 @@
               </a:spcBef>
             </a:pPr>
             <a:r>
-              <a:rPr lang="en-US" sz="1300">
+              <a:rPr lang="en-US" sz="1300" noProof="1">
                 <a:solidFill>
                   <a:srgbClr val="4E4E4E"/>
                 </a:solidFill>
@@ -6521,7 +6589,7 @@
               </a:rPr>
               <a:t>Контур длиннее 120 м (Ø20) — разбейте на два контура</a:t>
             </a:r>
-            <a:endParaRPr lang="en-US" sz="1300"/>
+            <a:endParaRPr lang="en-US" sz="1300" noProof="1"/>
           </a:p>
         </p:txBody>
       </p:sp>
@@ -6580,7 +6648,7 @@
               </a:lnSpc>
             </a:pPr>
             <a:r>
-              <a:rPr lang="en-US" sz="1100">
+              <a:rPr lang="en-US" sz="1100" noProof="1">
                 <a:solidFill>
                   <a:srgbClr val="818181"/>
                 </a:solidFill>
@@ -6589,7 +6657,7 @@
               </a:rPr>
               <a:t>09</a:t>
             </a:r>
-            <a:endParaRPr lang="en-US" sz="1100"/>
+            <a:endParaRPr lang="en-US" sz="1100" noProof="1"/>
           </a:p>
         </p:txBody>
       </p:sp>
@@ -6714,4 +6782,11 @@
     </a:fmtScheme>
   </a:themeElements>
 </a:theme>
+</file>
+
+<file path=customXml/provenance.xml><?xml version="1.0" encoding="utf-8"?>
+<provenance xmlns="urn:kimi:pptd:provenance">
+  <producer>Kimi Slides/Design</producer>
+  <statement>Built by Kimi Slides/Design with PPTD</statement>
+</provenance>
 </file>
</xml_diff>